<commit_message>
Align final report and presentation
</commit_message>
<xml_diff>
--- a/slides/Xoaif_Final.pptx
+++ b/slides/Xoaif_Final.pptx
@@ -456,17 +456,19 @@
           <a:lstStyle xmlns:a="http://schemas.openxmlformats.org/drawingml/2006/main"/>
           <a:p xmlns:a="http://schemas.openxmlformats.org/drawingml/2006/main">
             <a:r>
-              <a:t>Mở đầu bằng mục tiêu: biến dữ liệu bán hàng thành quy trình phân tích có thể kiểm tra và trình bày trung thực cả kết quả lẫn giới hạn.</a:t>
+              <a:t>Mở đầu: cửa hàng có dữ liệu giao dịch nhưng cần cách đọc thống nhất về xu hướng, khách hàng và sản phẩm thường mua cùng nhau.</a:t>
             </a:r>
           </a:p>
           <a:p xmlns:a="http://schemas.openxmlformats.org/drawingml/2006/main">
             <a:r>
-              <a:t/>
+              <a:t>
+              </a:t>
             </a:r>
           </a:p>
           <a:p xmlns:a="http://schemas.openxmlformats.org/drawingml/2006/main">
             <a:r>
-              <a:t>Nguồn: docs/PROJECT_GUIDE.md; README.md</a:t>
+              <a:t>
+              </a:t>
             </a:r>
           </a:p>
         </p:txBody>
@@ -536,17 +538,19 @@
           <a:lstStyle xmlns:a="http://schemas.openxmlformats.org/drawingml/2006/main"/>
           <a:p xmlns:a="http://schemas.openxmlformats.org/drawingml/2006/main">
             <a:r>
-              <a:t>24 cặp đã khóa; 21/24 lift trên 1 ở test là tiêu chí yếu. Bộ lọc DEV F3 dùng lift&gt;1, Kulczynski&gt;=0,5 và imbalance ratio&lt;=0,5; 1 cặp qua. Chỉ nên xem là giả thuyết A/B.</a:t>
+              <a:t>FP-Growth tìm cặp/tập sản phẩm thường cùng có trong giỏ. Support, confidence và lift đo tần suất liên hệ, không chứng minh nhân quả.</a:t>
             </a:r>
           </a:p>
           <a:p xmlns:a="http://schemas.openxmlformats.org/drawingml/2006/main">
             <a:r>
-              <a:t/>
+              <a:t>
+              </a:t>
             </a:r>
           </a:p>
           <a:p xmlns:a="http://schemas.openxmlformats.org/drawingml/2006/main">
             <a:r>
-              <a:t>Nguồn: docs/combo_recommendation_f3.md; docs/test_report.md</a:t>
+              <a:t>
+              </a:t>
             </a:r>
           </a:p>
         </p:txBody>
@@ -616,17 +620,19 @@
           <a:lstStyle xmlns:a="http://schemas.openxmlformats.org/drawingml/2006/main"/>
           <a:p xmlns:a="http://schemas.openxmlformats.org/drawingml/2006/main">
             <a:r>
-              <a:t>Không diễn giải thiếu nhãn thành không có phàn nàn. Không gửi văn bản ra dịch vụ ngoài nếu chưa duyệt nhà cung cấp và cách lưu dữ liệu.</a:t>
+              <a:t>Các cặp sản phẩm được xếp theo tần suất và mức đồng xuất hiện; có thể gợi ý bundle hoặc cách trưng bày để cân nhắc.</a:t>
             </a:r>
           </a:p>
           <a:p xmlns:a="http://schemas.openxmlformats.org/drawingml/2006/main">
             <a:r>
-              <a:t/>
+              <a:t>
+              </a:t>
             </a:r>
           </a:p>
           <a:p xmlns:a="http://schemas.openxmlformats.org/drawingml/2006/main">
             <a:r>
-              <a:t>Nguồn: docs/data_gap_report.md; docs/data_governance.md; docs/PROJECT_GUIDE.md</a:t>
+              <a:t>
+              </a:t>
             </a:r>
           </a:p>
         </p:txBody>
@@ -696,17 +702,19 @@
           <a:lstStyle xmlns:a="http://schemas.openxmlformats.org/drawingml/2006/main"/>
           <a:p xmlns:a="http://schemas.openxmlformats.org/drawingml/2006/main">
             <a:r>
-              <a:t>Chỉ demo các tab thật sự có trong app. Bộ lọc đổi aggregate local; không hiển thị ID khách/đơn. Khoảng tổng quan có tháng cuối chưa trọn.</a:t>
+              <a:t>Dashboard gồm tổng quan, phân khúc, combo, chất lượng dữ liệu và mô hình mua lại.</a:t>
             </a:r>
           </a:p>
           <a:p xmlns:a="http://schemas.openxmlformats.org/drawingml/2006/main">
             <a:r>
-              <a:t/>
+              <a:t>
+              </a:t>
             </a:r>
           </a:p>
           <a:p xmlns:a="http://schemas.openxmlformats.org/drawingml/2006/main">
             <a:r>
-              <a:t>Nguồn: src/app/streamlit_app.py; docs/DEFENSE_GUIDE.md</a:t>
+              <a:t>
+              </a:t>
             </a:r>
           </a:p>
         </p:txBody>
@@ -776,17 +784,19 @@
           <a:lstStyle xmlns:a="http://schemas.openxmlformats.org/drawingml/2006/main"/>
           <a:p xmlns:a="http://schemas.openxmlformats.org/drawingml/2006/main">
             <a:r>
-              <a:t>Dùng bảng này để chuyển từ kết quả sang các quyết định cần chủ dự án/giảng viên chốt. Phần xử lý cụ thể nằm trong PROJECT_GUIDE mục 7.</a:t>
+              <a:t>Đầu ra gồm kho phân tích, kết quả khách hàng/giỏ hàng, mô hình thử nghiệm, dashboard, báo cáo và slide.</a:t>
             </a:r>
           </a:p>
           <a:p xmlns:a="http://schemas.openxmlformats.org/drawingml/2006/main">
             <a:r>
-              <a:t/>
+              <a:t>
+              </a:t>
             </a:r>
           </a:p>
           <a:p xmlns:a="http://schemas.openxmlformats.org/drawingml/2006/main">
             <a:r>
-              <a:t>Nguồn: docs/PROJECT_GUIDE.md</a:t>
+              <a:t>
+              </a:t>
             </a:r>
           </a:p>
         </p:txBody>
@@ -856,17 +866,19 @@
           <a:lstStyle xmlns:a="http://schemas.openxmlformats.org/drawingml/2006/main"/>
           <a:p xmlns:a="http://schemas.openxmlformats.org/drawingml/2006/main">
             <a:r>
-              <a:t>Nêu điều kiện: dashboard cần outputs aggregate; sample là giả lập; runner hậu kiểm có thể chạy pytest nhưng không mở test hay fit. Ingestion chỉ chạy trên máy được cấp quyền API.</a:t>
+              <a:t>Demo theo thứ tự tổng quan doanh số, phân khúc khách, combo. Mở tab mô hình nếu giảng viên hỏi về ML.</a:t>
             </a:r>
           </a:p>
           <a:p xmlns:a="http://schemas.openxmlformats.org/drawingml/2006/main">
             <a:r>
-              <a:t/>
+              <a:t>
+              </a:t>
             </a:r>
           </a:p>
           <a:p xmlns:a="http://schemas.openxmlformats.org/drawingml/2006/main">
             <a:r>
-              <a:t>Nguồn: docs/PROJECT_GUIDE.md; scripts/run_all.py</a:t>
+              <a:t>
+              </a:t>
             </a:r>
           </a:p>
         </p:txBody>
@@ -936,17 +948,19 @@
           <a:lstStyle xmlns:a="http://schemas.openxmlformats.org/drawingml/2006/main"/>
           <a:p xmlns:a="http://schemas.openxmlformats.org/drawingml/2006/main">
             <a:r>
-              <a:t>Kết luận bằng những gì đã làm được, phần chưa có căn cứ và dữ liệu cần bổ sung. Mời câu hỏi.</a:t>
+              <a:t>Dự án biến dữ liệu giao dịch thành phân tích và dashboard. Các kết quả giúp hiểu dữ liệu và hình thành giả thuyết. Mời thầy cô đặt câu hỏi.</a:t>
             </a:r>
           </a:p>
           <a:p xmlns:a="http://schemas.openxmlformats.org/drawingml/2006/main">
             <a:r>
-              <a:t/>
+              <a:t>
+              </a:t>
             </a:r>
           </a:p>
           <a:p xmlns:a="http://schemas.openxmlformats.org/drawingml/2006/main">
             <a:r>
-              <a:t>Nguồn: docs/PROJECT_GUIDE.md; docs/DEFENSE_GUIDE.md</a:t>
+              <a:t>
+              </a:t>
             </a:r>
           </a:p>
         </p:txBody>
@@ -1016,17 +1030,19 @@
           <a:lstStyle xmlns:a="http://schemas.openxmlformats.org/drawingml/2006/main"/>
           <a:p xmlns:a="http://schemas.openxmlformats.org/drawingml/2006/main">
             <a:r>
-              <a:t>Nói rõ phạm vi ba bài toán. Bài toán C chưa đủ nhãn. Hai bài còn lại có kết quả nhưng cần nêu độ tin cậy và điều kiện diễn giải.</a:t>
+              <a:t>Ba câu hỏi của dự án: doanh thu thay đổi ra sao; khách có mua lại không; sản phẩm nào thường cùng xuất hiện trong giỏ.</a:t>
             </a:r>
           </a:p>
           <a:p xmlns:a="http://schemas.openxmlformats.org/drawingml/2006/main">
             <a:r>
-              <a:t/>
+              <a:t>
+              </a:t>
             </a:r>
           </a:p>
           <a:p xmlns:a="http://schemas.openxmlformats.org/drawingml/2006/main">
             <a:r>
-              <a:t>Nguồn: Ke_hoach_cuoi_cung_Xoaif_Garden.md; docs/PROJECT_GUIDE.md</a:t>
+              <a:t>
+              </a:t>
             </a:r>
           </a:p>
         </p:txBody>
@@ -1096,17 +1112,19 @@
           <a:lstStyle xmlns:a="http://schemas.openxmlformats.org/drawingml/2006/main"/>
           <a:p xmlns:a="http://schemas.openxmlformats.org/drawingml/2006/main">
             <a:r>
-              <a:t>Đi theo luồng từ trái sang phải. Client chỉ GET. Snapshot có manifest. HMAC thay định danh trước kho. Dashboard chỉ đọc bảng tổng hợp đã phát hành.</a:t>
+              <a:t>Luồng xử lý: giao dịch, chuẩn hóa, tạo đặc trưng, phân tích, trình bày. Công cụ chính: Python, Pandas, DuckDB, scikit-learn, mlxtend, Streamlit.</a:t>
             </a:r>
           </a:p>
           <a:p xmlns:a="http://schemas.openxmlformats.org/drawingml/2006/main">
             <a:r>
-              <a:t/>
+              <a:t>
+              </a:t>
             </a:r>
           </a:p>
           <a:p xmlns:a="http://schemas.openxmlformats.org/drawingml/2006/main">
             <a:r>
-              <a:t>Nguồn: docs/architecture_matrix.md; docs/data_governance.md; docs/PROJECT_GUIDE.md</a:t>
+              <a:t>
+              </a:t>
             </a:r>
           </a:p>
         </p:txBody>
@@ -1176,17 +1194,19 @@
           <a:lstStyle xmlns:a="http://schemas.openxmlformats.org/drawingml/2006/main"/>
           <a:p xmlns:a="http://schemas.openxmlformats.org/drawingml/2006/main">
             <a:r>
-              <a:t>Snapshot chứa nhiều khoảng thời gian; từng phân tích dùng cohort riêng. 12.011 là số đơn snapshot, 6.517 là số đơn DEV, 6.400 là status 3 DEV, 5.169 là khách đủ điều kiện scoring.</a:t>
+              <a:t>Nguồn là Pancake POS. 12.011 là số đơn trong snapshot; 6.517 là số đơn trong phạm vi DEV; trong đó 6.400 đơn có status 3.</a:t>
             </a:r>
           </a:p>
           <a:p xmlns:a="http://schemas.openxmlformats.org/drawingml/2006/main">
             <a:r>
-              <a:t/>
+              <a:t>
+              </a:t>
             </a:r>
           </a:p>
           <a:p xmlns:a="http://schemas.openxmlformats.org/drawingml/2006/main">
             <a:r>
-              <a:t>Nguồn: docs/canonical_numbers.md; docs/cohort_reconciliation.md</a:t>
+              <a:t>
+              </a:t>
             </a:r>
           </a:p>
         </p:txBody>
@@ -1256,17 +1276,19 @@
           <a:lstStyle xmlns:a="http://schemas.openxmlformats.org/drawingml/2006/main"/>
           <a:p xmlns:a="http://schemas.openxmlformats.org/drawingml/2006/main">
             <a:r>
-              <a:t>HMAC là pseudonymization, không phải ẩn danh tuyệt đối. Raw/restricted cần quyền truy cập và retention policy. Shared chỉ chứa aggregate.</a:t>
+              <a:t>Các bảng đơn, khách và sản phẩm được nối trong kho DuckDB. Định danh được giả danh hóa; dashboard dùng bảng tổng hợp.</a:t>
             </a:r>
           </a:p>
           <a:p xmlns:a="http://schemas.openxmlformats.org/drawingml/2006/main">
             <a:r>
-              <a:t/>
+              <a:t>
+              </a:t>
             </a:r>
           </a:p>
           <a:p xmlns:a="http://schemas.openxmlformats.org/drawingml/2006/main">
             <a:r>
-              <a:t>Nguồn: docs/data_governance.md; docs/PROJECT_GUIDE.md</a:t>
+              <a:t>
+              </a:t>
             </a:r>
           </a:p>
         </p:txBody>
@@ -1336,17 +1358,19 @@
           <a:lstStyle xmlns:a="http://schemas.openxmlformats.org/drawingml/2006/main"/>
           <a:p xmlns:a="http://schemas.openxmlformats.org/drawingml/2006/main">
             <a:r>
-              <a:t>Nêu điều kiện trưởng thành cohort. Retention 180 ngày dùng định nghĩa ngày mua sau. CLV là doanh thu ghi nhận 180 ngày đầu, không phải CLV dự báo hay lợi nhuận.</a:t>
+              <a:t>Retention 180 ngày là 10,40% trong cohort đủ theo dõi. CLV 512.934 đồng/khách là doanh thu lịch sử 180 ngày đầu, không phải dự báo hay lợi nhuận.</a:t>
             </a:r>
           </a:p>
           <a:p xmlns:a="http://schemas.openxmlformats.org/drawingml/2006/main">
             <a:r>
-              <a:t/>
+              <a:t>
+              </a:t>
             </a:r>
           </a:p>
           <a:p xmlns:a="http://schemas.openxmlformats.org/drawingml/2006/main">
             <a:r>
-              <a:t>Nguồn: docs/customer_value_dev.md; outputs/tables/customer_retention_dev.csv</a:t>
+              <a:t>
+              </a:t>
             </a:r>
           </a:p>
         </p:txBody>
@@ -1416,17 +1440,19 @@
           <a:lstStyle xmlns:a="http://schemas.openxmlformats.org/drawingml/2006/main"/>
           <a:p xmlns:a="http://schemas.openxmlformats.org/drawingml/2006/main">
             <a:r>
-              <a:t>K=2 gần với luật mua một lần/lặp lại. Silhouette là độ tách hình học. Sáu nhóm RFM rule-based tạo giả thuyết mô tả; chưa chứng minh hiệu quả tiếp cận.</a:t>
+              <a:t>RFM gồm Recency, Frequency và Monetary. K-Means K=2 chủ yếu tách khách mua một lần và mua lặp lại; đây là mô tả hành vi.</a:t>
             </a:r>
           </a:p>
           <a:p xmlns:a="http://schemas.openxmlformats.org/drawingml/2006/main">
             <a:r>
-              <a:t/>
+              <a:t>
+              </a:t>
             </a:r>
           </a:p>
           <a:p xmlns:a="http://schemas.openxmlformats.org/drawingml/2006/main">
             <a:r>
-              <a:t>Nguồn: docs/customer_value_dev.md; docs/day2_summary.md; docs/PROJECT_GUIDE.md</a:t>
+              <a:t>
+              </a:t>
             </a:r>
           </a:p>
         </p:txBody>
@@ -1496,17 +1522,19 @@
           <a:lstStyle xmlns:a="http://schemas.openxmlformats.org/drawingml/2006/main"/>
           <a:p xmlns:a="http://schemas.openxmlformats.org/drawingml/2006/main">
             <a:r>
-              <a:t>Đọc biểu đồ cùng thiết kế đánh giá. Điểm test cao hơn nhưng DEV OOF không tái hiện. Không kết luận mô hình tốt hoặc sẵn sàng triển khai.</a:t>
+              <a:t>Logistic Regression dùng đặc trưng lịch sử để tạo xác suất mua lại trong 180 ngày sau mốc T.</a:t>
             </a:r>
           </a:p>
           <a:p xmlns:a="http://schemas.openxmlformats.org/drawingml/2006/main">
             <a:r>
-              <a:t/>
+              <a:t>
+              </a:t>
             </a:r>
           </a:p>
           <a:p xmlns:a="http://schemas.openxmlformats.org/drawingml/2006/main">
             <a:r>
-              <a:t>Nguồn: docs/test_report.md; docs/cohort_mismatch_analysis.md</a:t>
+              <a:t>
+              </a:t>
             </a:r>
           </a:p>
         </p:txBody>
@@ -1576,17 +1604,19 @@
           <a:lstStyle xmlns:a="http://schemas.openxmlformats.org/drawingml/2006/main"/>
           <a:p xmlns:a="http://schemas.openxmlformats.org/drawingml/2006/main">
             <a:r>
-              <a:t>Trình bày định nghĩa feature-as-of T, temporal folds, baseline và bootstrap. Nhắc test đã mở một lần. Nêu chính xác khác biệt ngày biên và không gọi kết quả là đạt trọn protocol.</a:t>
+              <a:t>Đặc trưng được tính trước T; nhãn được suy ra từ giao dịch hợp lệ trong 180 ngày sau T. Đánh giá chia theo thời gian.</a:t>
             </a:r>
           </a:p>
           <a:p xmlns:a="http://schemas.openxmlformats.org/drawingml/2006/main">
             <a:r>
-              <a:t/>
+              <a:t>
+              </a:t>
             </a:r>
           </a:p>
           <a:p xmlns:a="http://schemas.openxmlformats.org/drawingml/2006/main">
             <a:r>
-              <a:t>Nguồn: docs/data_protocol.md; docs/test_provenance_note.md; outputs/metrics/test_opened.lock.json</a:t>
+              <a:t>
+              </a:t>
             </a:r>
           </a:p>
         </p:txBody>
@@ -5837,7 +5867,7 @@
                 <a:ea typeface="Arial"/>
                 <a:cs typeface="Arial"/>
               </a:rPr>
-              <a:t>Bộ lọc DEV giữ lại một giả thuyết combo</a:t>
+              <a:t>Tìm sản phẩm thường xuất hiện cùng giỏ</a:t>
             </a:r>
           </a:p>
         </p:txBody>
@@ -6345,7 +6375,7 @@
                 <a:ea typeface="Arial"/>
                 <a:cs typeface="Arial"/>
               </a:rPr>
-              <a:t>24</a:t>
+              <a:t>FP</a:t>
             </a:r>
           </a:p>
         </p:txBody>
@@ -6504,7 +6534,7 @@
                 <a:ea typeface="Arial"/>
                 <a:cs typeface="Arial"/>
               </a:rPr>
-              <a:t>cặp đã khóa</a:t>
+              <a:t>FP-Growth</a:t>
             </a:r>
           </a:p>
         </p:txBody>
@@ -6663,7 +6693,7 @@
                 <a:ea typeface="Arial"/>
                 <a:cs typeface="Arial"/>
               </a:rPr>
-              <a:t>1</a:t>
+              <a:t>SUP</a:t>
             </a:r>
           </a:p>
         </p:txBody>
@@ -6822,7 +6852,7 @@
                 <a:ea typeface="Arial"/>
                 <a:cs typeface="Arial"/>
               </a:rPr>
-              <a:t>qua lọc DEV F3</a:t>
+              <a:t>CONF</a:t>
             </a:r>
           </a:p>
         </p:txBody>
@@ -6981,7 +7011,7 @@
                 <a:ea typeface="Arial"/>
                 <a:cs typeface="Arial"/>
               </a:rPr>
-              <a:t>21 / 24</a:t>
+              <a:t>LIFT</a:t>
             </a:r>
           </a:p>
         </p:txBody>
@@ -7140,7 +7170,7 @@
                 <a:ea typeface="Arial"/>
                 <a:cs typeface="Arial"/>
               </a:rPr>
-              <a:t>lift &gt; 1 trong test</a:t>
+              <a:t>so với mức đồng xuất hiện nền</a:t>
             </a:r>
           </a:p>
         </p:txBody>
@@ -7299,7 +7329,7 @@
                 <a:ea typeface="Arial"/>
                 <a:cs typeface="Arial"/>
               </a:rPr>
-              <a:t>Lift, confidence, support</a:t>
+              <a:t>Support · confidence · lift</a:t>
             </a:r>
           </a:p>
         </p:txBody>
@@ -7458,7 +7488,7 @@
                 <a:ea typeface="Arial"/>
                 <a:cs typeface="Arial"/>
               </a:rPr>
-              <a:t>Đo đồng xuất hiện trong giỏ. Không cho biết sản phẩm gây ra việc mua món còn lại.</a:t>
+              <a:t>Các thước đo xếp hạng cặp sản phẩm có xu hướng cùng xuất hiện trong giỏ.</a:t>
             </a:r>
           </a:p>
         </p:txBody>
@@ -7617,7 +7647,7 @@
                 <a:ea typeface="Arial"/>
                 <a:cs typeface="Arial"/>
               </a:rPr>
-              <a:t>Thiếu giá vốn và tồn kho</a:t>
+              <a:t>Ứng dụng</a:t>
             </a:r>
           </a:p>
         </p:txBody>
@@ -7776,7 +7806,7 @@
                 <a:ea typeface="Arial"/>
                 <a:cs typeface="Arial"/>
               </a:rPr>
-              <a:t>Chưa tính margin, giá giảm hay hòa vốn.</a:t>
+              <a:t>Tạo giả thuyết bundle hoặc trưng bày để cửa hàng cân nhắc.</a:t>
             </a:r>
           </a:p>
         </p:txBody>
@@ -7997,7 +8027,7 @@
                 <a:ea typeface="Arial"/>
                 <a:cs typeface="Arial"/>
               </a:rPr>
-              <a:t>BÀI TOÁN C</a:t>
+              <a:t>KẾT QUẢ GIỎ HÀNG</a:t>
             </a:r>
           </a:p>
         </p:txBody>
@@ -8156,7 +8186,7 @@
                 <a:ea typeface="Arial"/>
                 <a:cs typeface="Arial"/>
               </a:rPr>
-              <a:t>Bài toán phản hồi đang chờ dữ liệu có nhãn</a:t>
+              <a:t>Các cặp sản phẩm gợi ý cách kết hợp</a:t>
             </a:r>
           </a:p>
         </p:txBody>
@@ -8664,7 +8694,7 @@
                 <a:ea typeface="Arial"/>
                 <a:cs typeface="Arial"/>
               </a:rPr>
-              <a:t>Đầu vào cần có</a:t>
+              <a:t>Đầu vào</a:t>
             </a:r>
           </a:p>
         </p:txBody>
@@ -8856,7 +8886,7 @@
                 <a:ea typeface="Arial"/>
                 <a:cs typeface="Arial"/>
               </a:rPr>
-              <a:t>Nguồn review/ghi chú được phép dùng</a:t>
+              <a:t>Đơn hàng và dòng sản phẩm</a:t>
             </a:r>
           </a:p>
         </p:txBody>
@@ -9048,7 +9078,7 @@
                 <a:ea typeface="Arial"/>
                 <a:cs typeface="Arial"/>
               </a:rPr>
-              <a:t>Ẩn danh và kiểm kê độ phủ</a:t>
+              <a:t>Giỏ hàng hợp lệ</a:t>
             </a:r>
           </a:p>
         </p:txBody>
@@ -9240,7 +9270,7 @@
                 <a:ea typeface="Arial"/>
                 <a:cs typeface="Arial"/>
               </a:rPr>
-              <a:t>Taxonomy được giảng viên/chủ dự án duyệt</a:t>
+              <a:t>Thuật toán FP-Growth</a:t>
             </a:r>
           </a:p>
         </p:txBody>
@@ -9432,7 +9462,7 @@
                 <a:ea typeface="Arial"/>
                 <a:cs typeface="Arial"/>
               </a:rPr>
-              <a:t>Nhãn tay và tập đánh giá giữ riêng</a:t>
+              <a:t>Support, confidence và lift</a:t>
             </a:r>
           </a:p>
         </p:txBody>
@@ -9622,7 +9652,7 @@
                 <a:ea typeface="Arial"/>
                 <a:cs typeface="Arial"/>
               </a:rPr>
-              <a:t>Nếu đủ mẫu</a:t>
+              <a:t>Kết quả</a:t>
             </a:r>
           </a:p>
         </p:txBody>
@@ -9781,7 +9811,7 @@
                 <a:ea typeface="Arial"/>
                 <a:cs typeface="Arial"/>
               </a:rPr>
-              <a:t>Gán nhãn 200–300 mẫu; hai người gán một phần để đo đồng thuận; TF-IDF + Logistic Regression; báo precision/recall/F1 từng lớp.</a:t>
+              <a:t>Các cặp sản phẩm được xếp hạng theo tần suất và mức độ đồng xuất hiện trong giỏ.</a:t>
             </a:r>
           </a:p>
         </p:txBody>
@@ -9940,7 +9970,7 @@
                 <a:ea typeface="Arial"/>
                 <a:cs typeface="Arial"/>
               </a:rPr>
-              <a:t>Nếu thiếu mẫu</a:t>
+              <a:t>Ứng dụng</a:t>
             </a:r>
           </a:p>
         </p:txBody>
@@ -10099,7 +10129,7 @@
                 <a:ea typeface="Arial"/>
                 <a:cs typeface="Arial"/>
               </a:rPr>
-              <a:t>Báo giới hạn và đề xuất khảo sát sau mua.</a:t>
+              <a:t>Kết quả giúp hình thành giả thuyết bundle hoặc gợi ý trưng bày sản phẩm.</a:t>
             </a:r>
           </a:p>
         </p:txBody>
@@ -10479,7 +10509,7 @@
                 <a:ea typeface="Arial"/>
                 <a:cs typeface="Arial"/>
               </a:rPr>
-              <a:t>Dashboard chạy offline từ aggregate</a:t>
+              <a:t>Dashboard kết quả phân tích</a:t>
             </a:r>
           </a:p>
         </p:txBody>
@@ -12732,7 +12762,7 @@
                 <a:ea typeface="Arial"/>
                 <a:cs typeface="Arial"/>
               </a:rPr>
-              <a:t>Chỉ đọc CSV/JSON local. Không API, không raw, không định danh khách.</a:t>
+              <a:t>Tổng quan doanh số · Phân khúc khách · Combo gợi ý · Chất lượng dữ liệu · Mô hình mua lại</a:t>
             </a:r>
           </a:p>
         </p:txBody>
@@ -12953,7 +12983,7 @@
                 <a:ea typeface="Arial"/>
                 <a:cs typeface="Arial"/>
               </a:rPr>
-              <a:t>KẾ HOẠCH TIẾP THEO</a:t>
+              <a:t>SẢN PHẨM DỰ ÁN</a:t>
             </a:r>
           </a:p>
         </p:txBody>
@@ -13112,7 +13142,7 @@
                 <a:ea typeface="Arial"/>
                 <a:cs typeface="Arial"/>
               </a:rPr>
-              <a:t>Bốn quyết định mở khóa bước tiếp theo</a:t>
+              <a:t>Kết quả được trình bày qua bốn phần</a:t>
             </a:r>
           </a:p>
         </p:txBody>
@@ -13620,7 +13650,7 @@
                 <a:ea typeface="Arial"/>
                 <a:cs typeface="Arial"/>
               </a:rPr>
-              <a:t>Giá vốn</a:t>
+              <a:t>Dữ liệu</a:t>
             </a:r>
           </a:p>
         </p:txBody>
@@ -13779,7 +13809,7 @@
                 <a:ea typeface="Arial"/>
                 <a:cs typeface="Arial"/>
               </a:rPr>
-              <a:t>Export có ngày hiệu lực; xác nhận imported price.</a:t>
+              <a:t>Giao dịch, khách hàng và sản phẩm</a:t>
             </a:r>
           </a:p>
         </p:txBody>
@@ -13969,7 +13999,7 @@
                 <a:ea typeface="Arial"/>
                 <a:cs typeface="Arial"/>
               </a:rPr>
-              <a:t>Phản hồi</a:t>
+              <a:t>Phân tích</a:t>
             </a:r>
           </a:p>
         </p:txBody>
@@ -14128,7 +14158,7 @@
                 <a:ea typeface="Arial"/>
                 <a:cs typeface="Arial"/>
               </a:rPr>
-              <a:t>Nguồn được phép, người gán nhãn, quy tắc ẩn danh.</a:t>
+              <a:t>Xu hướng bán hàng, retention, CLV và RFM</a:t>
             </a:r>
           </a:p>
         </p:txBody>
@@ -14318,7 +14348,7 @@
                 <a:ea typeface="Arial"/>
                 <a:cs typeface="Arial"/>
               </a:rPr>
-              <a:t>Hành động</a:t>
+              <a:t>ML và giỏ hàng</a:t>
             </a:r>
           </a:p>
         </p:txBody>
@@ -14477,7 +14507,7 @@
                 <a:ea typeface="Arial"/>
                 <a:cs typeface="Arial"/>
               </a:rPr>
-              <a:t>Mục tiêu khách, ngân sách, top-k và KPI.</a:t>
+              <a:t>Logistic Regression và FP-Growth</a:t>
             </a:r>
           </a:p>
         </p:txBody>
@@ -14667,7 +14697,7 @@
                 <a:ea typeface="Arial"/>
                 <a:cs typeface="Arial"/>
               </a:rPr>
-              <a:t>Quyền dữ liệu</a:t>
+              <a:t>Trình bày</a:t>
             </a:r>
           </a:p>
         </p:txBody>
@@ -14826,7 +14856,7 @@
                 <a:ea typeface="Arial"/>
                 <a:cs typeface="Arial"/>
               </a:rPr>
-              <a:t>Ai truy cập raw; hạn lưu và ngày xóa.</a:t>
+              <a:t>Dashboard, báo cáo và slide thuyết trình</a:t>
             </a:r>
           </a:p>
         </p:txBody>
@@ -15016,7 +15046,7 @@
                 <a:ea typeface="Arial"/>
                 <a:cs typeface="Arial"/>
               </a:rPr>
-              <a:t>Mỗi đầu vào sẽ tạo phạm vi xử lý và quyết định phân tích rõ ràng trước khi chạy.</a:t>
+              <a:t>Kết quả giúp hiểu hoạt động bán hàng và hình thành giả thuyết tiếp theo.</a:t>
             </a:r>
           </a:p>
         </p:txBody>
@@ -15237,7 +15267,7 @@
                 <a:ea typeface="Arial"/>
                 <a:cs typeface="Arial"/>
               </a:rPr>
-              <a:t>VẬN HÀNH</a:t>
+              <a:t>DEMO DASHBOARD</a:t>
             </a:r>
           </a:p>
         </p:txBody>
@@ -15396,7 +15426,7 @@
                 <a:ea typeface="Arial"/>
                 <a:cs typeface="Arial"/>
               </a:rPr>
-              <a:t>Ba cách sử dụng repo sau khi clone</a:t>
+              <a:t>Từ tổng quan đến gợi ý sản phẩm</a:t>
             </a:r>
           </a:p>
         </p:txBody>
@@ -15904,7 +15934,7 @@
                 <a:ea typeface="Arial"/>
                 <a:cs typeface="Arial"/>
               </a:rPr>
-              <a:t>Xem dashboard</a:t>
+              <a:t>01  Tổng quan</a:t>
             </a:r>
           </a:p>
         </p:txBody>
@@ -16063,7 +16093,7 @@
                 <a:ea typeface="Arial"/>
                 <a:cs typeface="Arial"/>
               </a:rPr>
-              <a:t>.venv\Scripts\streamlit.exe run src/app/streamlit_app.py</a:t>
+              <a:t>Doanh số và xu hướng theo tháng</a:t>
             </a:r>
           </a:p>
         </p:txBody>
@@ -16253,7 +16283,7 @@
                 <a:ea typeface="Arial"/>
                 <a:cs typeface="Arial"/>
               </a:rPr>
-              <a:t>Sinh sample</a:t>
+              <a:t>02  Phân khúc</a:t>
             </a:r>
           </a:p>
         </p:txBody>
@@ -16412,7 +16442,7 @@
                 <a:ea typeface="Arial"/>
                 <a:cs typeface="Arial"/>
               </a:rPr>
-              <a:t>.venv\Scripts\python.exe scripts/make_sample_data.py</a:t>
+              <a:t>Cơ cấu khách theo hành vi mua</a:t>
             </a:r>
           </a:p>
         </p:txBody>
@@ -16602,7 +16632,7 @@
                 <a:ea typeface="Arial"/>
                 <a:cs typeface="Arial"/>
               </a:rPr>
-              <a:t>Hậu kiểm</a:t>
+              <a:t>03  Combo</a:t>
             </a:r>
           </a:p>
         </p:txBody>
@@ -16761,7 +16791,7 @@
                 <a:ea typeface="Arial"/>
                 <a:cs typeface="Arial"/>
               </a:rPr>
-              <a:t>.venv\Scripts\python.exe scripts/run_all.py</a:t>
+              <a:t>Sản phẩm thường xuất hiện cùng giỏ</a:t>
             </a:r>
           </a:p>
         </p:txBody>
@@ -16951,7 +16981,7 @@
                 <a:ea typeface="Arial"/>
                 <a:cs typeface="Arial"/>
               </a:rPr>
-              <a:t>Test đã mở: runner không gọi evaluator hoặc fit lại mô hình.</a:t>
+              <a:t>Demo tập trung vào kết quả phân tích và cách đọc từng tab dashboard.</a:t>
             </a:r>
           </a:p>
         </p:txBody>
@@ -17298,7 +17328,7 @@
                 <a:ea typeface="Arial"/>
                 <a:cs typeface="Arial"/>
               </a:rPr>
-              <a:t>Quy trình và sản phẩm đã có.</a:t>
+              <a:t>Phân tích khách và sản phẩm</a:t>
             </a:r>
           </a:p>
           <a:p xmlns:a="http://schemas.openxmlformats.org/drawingml/2006/main">
@@ -17321,7 +17351,7 @@
                 <a:ea typeface="Arial"/>
                 <a:cs typeface="Arial"/>
               </a:rPr>
-              <a:t>Tác động kinh doanh cần kiểm chứng.</a:t>
+              <a:t>Kết quả mô tả hành vi mua</a:t>
             </a:r>
           </a:p>
         </p:txBody>
@@ -17511,7 +17541,7 @@
                 <a:ea typeface="Arial"/>
                 <a:cs typeface="Arial"/>
               </a:rPr>
-              <a:t>Đã làm được</a:t>
+              <a:t>Kết quả</a:t>
             </a:r>
           </a:p>
         </p:txBody>
@@ -17670,7 +17700,7 @@
                 <a:ea typeface="Arial"/>
                 <a:cs typeface="Arial"/>
               </a:rPr>
-              <a:t>Kho · phân tích mô tả · dashboard · báo cáo · kiểm soát dữ liệu</a:t>
+              <a:t>Retention · CLV mô tả · phân khúc RFM · cặp sản phẩm</a:t>
             </a:r>
           </a:p>
         </p:txBody>
@@ -17829,7 +17859,7 @@
                 <a:ea typeface="Arial"/>
                 <a:cs typeface="Arial"/>
               </a:rPr>
-              <a:t>Còn cần</a:t>
+              <a:t>Sản phẩm</a:t>
             </a:r>
           </a:p>
         </p:txBody>
@@ -17988,7 +18018,7 @@
                 <a:ea typeface="Arial"/>
                 <a:cs typeface="Arial"/>
               </a:rPr>
-              <a:t>Giá vốn · phản hồi có nhãn · thử nghiệm hành động</a:t>
+              <a:t>Dashboard · báo cáo · slide trình bày</a:t>
             </a:r>
           </a:p>
         </p:txBody>
@@ -18527,7 +18557,7 @@
                 <a:ea typeface="Arial"/>
                 <a:cs typeface="Arial"/>
               </a:rPr>
-              <a:t>Ba câu hỏi, một quy trình dữ liệu</a:t>
+              <a:t>Từ dữ liệu bán hàng đến câu trả lời kinh doanh</a:t>
             </a:r>
           </a:p>
         </p:txBody>
@@ -19452,7 +19482,7 @@
                 <a:ea typeface="Arial"/>
                 <a:cs typeface="Arial"/>
               </a:rPr>
-              <a:t>Nguồn phản hồi có đủ dữ liệu để phân loại vấn đề không?</a:t>
+              <a:t>Xu hướng doanh thu thay đổi ra sao theo thời gian?</a:t>
             </a:r>
           </a:p>
         </p:txBody>
@@ -19611,7 +19641,7 @@
                 <a:ea typeface="Arial"/>
                 <a:cs typeface="Arial"/>
               </a:rPr>
-              <a:t>Mục tiêu là hỗ trợ mô tả và hình thành giả thuyết. Tác động kinh doanh cần thử nghiệm riêng.</a:t>
+              <a:t>Kết quả giúp mô tả khách hàng và gợi ý sản phẩm thường mua cùng nhau.</a:t>
             </a:r>
           </a:p>
         </p:txBody>
@@ -19991,7 +20021,7 @@
                 <a:ea typeface="Arial"/>
                 <a:cs typeface="Arial"/>
               </a:rPr>
-              <a:t>Từ API đến dashboard qua năm tầng</a:t>
+              <a:t>Quy trình phân tích dữ liệu</a:t>
             </a:r>
           </a:p>
         </p:txBody>
@@ -20532,7 +20562,7 @@
                 <a:ea typeface="Arial"/>
                 <a:cs typeface="Arial"/>
               </a:rPr>
-              <a:t>1  Nguồn</a:t>
+              <a:t>1  Dữ liệu bán hàng</a:t>
             </a:r>
           </a:p>
         </p:txBody>
@@ -20939,7 +20969,7 @@
                 <a:ea typeface="Arial"/>
                 <a:cs typeface="Arial"/>
               </a:rPr>
-              <a:t>2  Thu nhận</a:t>
+              <a:t>2  Chuẩn hóa</a:t>
             </a:r>
           </a:p>
         </p:txBody>
@@ -21346,7 +21376,7 @@
                 <a:ea typeface="Arial"/>
                 <a:cs typeface="Arial"/>
               </a:rPr>
-              <a:t>3  Kho &amp; xử lý</a:t>
+              <a:t>3  Tạo đặc trưng</a:t>
             </a:r>
           </a:p>
         </p:txBody>
@@ -21753,7 +21783,7 @@
                 <a:ea typeface="Arial"/>
                 <a:cs typeface="Arial"/>
               </a:rPr>
-              <a:t>4  Khai phá</a:t>
+              <a:t>4  Phân tích</a:t>
             </a:r>
           </a:p>
         </p:txBody>
@@ -22160,7 +22190,7 @@
                 <a:ea typeface="Arial"/>
                 <a:cs typeface="Arial"/>
               </a:rPr>
-              <a:t>5  Sử dụng</a:t>
+              <a:t>5  Trình bày</a:t>
             </a:r>
           </a:p>
         </p:txBody>
@@ -22501,7 +22531,7 @@
                 <a:ea typeface="Arial"/>
                 <a:cs typeface="Arial"/>
               </a:rPr>
-              <a:t>Raw và restricted ở máy được cấp quyền. Chỉ bảng tổng hợp đã rà soát đi tới giao diện.</a:t>
+              <a:t>Dữ liệu được chuẩn hóa trước phân tích; báo cáo và dashboard trình bày kết quả tổng hợp.</a:t>
             </a:r>
           </a:p>
         </p:txBody>
@@ -22881,7 +22911,7 @@
                 <a:ea typeface="Arial"/>
                 <a:cs typeface="Arial"/>
               </a:rPr>
-              <a:t>Snapshot lớn hơn phạm vi phân tích</a:t>
+              <a:t>Phạm vi dữ liệu phân tích</a:t>
             </a:r>
           </a:p>
         </p:txBody>
@@ -24566,7 +24596,7 @@
                 <a:ea typeface="Arial"/>
                 <a:cs typeface="Arial"/>
               </a:rPr>
-              <a:t>Cohort scoring mua lại: 5.169 khách. Không đánh đồng số đơn với số khách.</a:t>
+              <a:t>Phân tích dùng giao dịch hợp lệ trong giai đoạn hoạt động của cửa hàng.</a:t>
             </a:r>
           </a:p>
         </p:txBody>
@@ -24946,7 +24976,7 @@
                 <a:ea typeface="Arial"/>
                 <a:cs typeface="Arial"/>
               </a:rPr>
-              <a:t>Dữ liệu được tách theo mức nhạy cảm</a:t>
+              <a:t>Từ dữ liệu nguồn đến kết quả phân tích</a:t>
             </a:r>
           </a:p>
         </p:txBody>
@@ -25454,7 +25484,7 @@
                 <a:ea typeface="Arial"/>
                 <a:cs typeface="Arial"/>
               </a:rPr>
-              <a:t>RAW</a:t>
+              <a:t>DỮ LIỆU NGUỒN</a:t>
             </a:r>
           </a:p>
         </p:txBody>
@@ -25644,7 +25674,7 @@
                 <a:ea typeface="Arial"/>
                 <a:cs typeface="Arial"/>
               </a:rPr>
-              <a:t>data/raw</a:t>
+              <a:t>Đơn · khách · sản phẩm</a:t>
             </a:r>
           </a:p>
         </p:txBody>
@@ -25803,7 +25833,7 @@
                 <a:ea typeface="Arial"/>
                 <a:cs typeface="Arial"/>
               </a:rPr>
-              <a:t>API gốc</a:t>
+              <a:t>Pancake POS</a:t>
             </a:r>
           </a:p>
           <a:p xmlns:a="http://schemas.openxmlformats.org/drawingml/2006/main">
@@ -25826,7 +25856,7 @@
                 <a:ea typeface="Arial"/>
                 <a:cs typeface="Arial"/>
               </a:rPr>
-              <a:t>Có thể có PII</a:t>
+              <a:t>Dữ liệu giao dịch</a:t>
             </a:r>
           </a:p>
           <a:p xmlns:a="http://schemas.openxmlformats.org/drawingml/2006/main">
@@ -25849,7 +25879,7 @@
                 <a:ea typeface="Arial"/>
                 <a:cs typeface="Arial"/>
               </a:rPr>
-              <a:t>Chỉ giữ cục bộ</a:t>
+              <a:t>Nguồn đầu vào</a:t>
             </a:r>
           </a:p>
         </p:txBody>
@@ -26008,7 +26038,7 @@
                 <a:ea typeface="Arial"/>
                 <a:cs typeface="Arial"/>
               </a:rPr>
-              <a:t>RESTRICTED</a:t>
+              <a:t>KHO PHÂN TÍCH</a:t>
             </a:r>
           </a:p>
         </p:txBody>
@@ -26198,7 +26228,7 @@
                 <a:ea typeface="Arial"/>
                 <a:cs typeface="Arial"/>
               </a:rPr>
-              <a:t>data/restricted</a:t>
+              <a:t>DuckDB · HMAC</a:t>
             </a:r>
           </a:p>
         </p:txBody>
@@ -26357,7 +26387,7 @@
                 <a:ea typeface="Arial"/>
                 <a:cs typeface="Arial"/>
               </a:rPr>
-              <a:t>DuckDB + HMAC</a:t>
+              <a:t>Lưu trữ có kiểm soát</a:t>
             </a:r>
           </a:p>
           <a:p xmlns:a="http://schemas.openxmlformats.org/drawingml/2006/main">
@@ -26380,7 +26410,7 @@
                 <a:ea typeface="Arial"/>
                 <a:cs typeface="Arial"/>
               </a:rPr>
-              <a:t>Liên kết lịch sử</a:t>
+              <a:t>Python · Pandas</a:t>
             </a:r>
           </a:p>
           <a:p xmlns:a="http://schemas.openxmlformats.org/drawingml/2006/main">
@@ -26403,7 +26433,7 @@
                 <a:ea typeface="Arial"/>
                 <a:cs typeface="Arial"/>
               </a:rPr>
-              <a:t>Không chia sẻ</a:t>
+              <a:t>Tạo feature và chỉ số</a:t>
             </a:r>
           </a:p>
         </p:txBody>
@@ -26562,7 +26592,7 @@
                 <a:ea typeface="Arial"/>
                 <a:cs typeface="Arial"/>
               </a:rPr>
-              <a:t>SHARED</a:t>
+              <a:t>KẾT QUẢ</a:t>
             </a:r>
           </a:p>
         </p:txBody>
@@ -26752,7 +26782,7 @@
                 <a:ea typeface="Arial"/>
                 <a:cs typeface="Arial"/>
               </a:rPr>
-              <a:t>outputs</a:t>
+              <a:t>Dashboard · PDF</a:t>
             </a:r>
           </a:p>
         </p:txBody>
@@ -26911,7 +26941,7 @@
                 <a:ea typeface="Arial"/>
                 <a:cs typeface="Arial"/>
               </a:rPr>
-              <a:t>CSV / JSON aggregate</a:t>
+              <a:t>Chỉ số tổng hợp</a:t>
             </a:r>
           </a:p>
           <a:p xmlns:a="http://schemas.openxmlformats.org/drawingml/2006/main">
@@ -26934,7 +26964,7 @@
                 <a:ea typeface="Arial"/>
                 <a:cs typeface="Arial"/>
               </a:rPr>
-              <a:t>Đã rà soát schema</a:t>
+              <a:t>Trình bày kết quả</a:t>
             </a:r>
           </a:p>
           <a:p xmlns:a="http://schemas.openxmlformats.org/drawingml/2006/main">
@@ -26957,7 +26987,7 @@
                 <a:ea typeface="Arial"/>
                 <a:cs typeface="Arial"/>
               </a:rPr>
-              <a:t>Dashboard và báo cáo</a:t>
+              <a:t>Sản phẩm phân tích</a:t>
             </a:r>
           </a:p>
         </p:txBody>
@@ -27116,7 +27146,7 @@
                 <a:ea typeface="Arial"/>
                 <a:cs typeface="Arial"/>
               </a:rPr>
-              <a:t>API key chỉ nằm trong xoaif.env cục bộ; không commit, không ghi vào log.</a:t>
+              <a:t>Định danh được thay bằng mã giả danh trong kho phân tích.</a:t>
             </a:r>
           </a:p>
         </p:txBody>
@@ -27275,7 +27305,7 @@
                 <a:ea typeface="Arial"/>
                 <a:cs typeface="Arial"/>
               </a:rPr>
-              <a:t>Dashboard không đọc raw/restricted và không gọi mạng.</a:t>
+              <a:t>Dashboard trình bày bảng tổng hợp đã chuẩn hóa.</a:t>
             </a:r>
           </a:p>
         </p:txBody>
@@ -27655,7 +27685,7 @@
                 <a:ea typeface="Arial"/>
                 <a:cs typeface="Arial"/>
               </a:rPr>
-              <a:t>Retention tăng theo kỳ hạn, nhưng vẫn thấp</a:t>
+              <a:t>Giá trị khách hàng trong 180 ngày</a:t>
             </a:r>
           </a:p>
         </p:txBody>
@@ -29877,7 +29907,7 @@
                 <a:ea typeface="Arial"/>
                 <a:cs typeface="Arial"/>
               </a:rPr>
-              <a:t>mua lại trong 180 ngày</a:t>
+              <a:t>khách mua lại</a:t>
             </a:r>
           </a:p>
           <a:p xmlns:a="http://schemas.openxmlformats.org/drawingml/2006/main">
@@ -29900,7 +29930,7 @@
                 <a:ea typeface="Arial"/>
                 <a:cs typeface="Arial"/>
               </a:rPr>
-              <a:t>3.508 khách đủ theo dõi</a:t>
+              <a:t>3.508 khách theo dõi</a:t>
             </a:r>
           </a:p>
         </p:txBody>
@@ -30082,7 +30112,7 @@
                 <a:ea typeface="Arial"/>
                 <a:cs typeface="Arial"/>
               </a:rPr>
-              <a:t>Không phải dự báo hoặc lợi nhuận.</a:t>
+              <a:t>CLV là doanh thu lịch sử, không phải dự báo hay lợi nhuận.</a:t>
             </a:r>
           </a:p>
         </p:txBody>
@@ -30462,7 +30492,7 @@
                 <a:ea typeface="Arial"/>
                 <a:cs typeface="Arial"/>
               </a:rPr>
-              <a:t>K=2 mô tả tần suất, chưa xác nhận hành động</a:t>
+              <a:t>Phân khúc khách hàng theo RFM</a:t>
             </a:r>
           </a:p>
         </p:txBody>
@@ -32385,7 +32415,7 @@
                 <a:ea typeface="Arial"/>
                 <a:cs typeface="Arial"/>
               </a:rPr>
-              <a:t>Không gọi cụm là VIP hoặc churn risk khi chưa có outcome xác nhận.</a:t>
+              <a:t>K=2 cho thấy hai nhóm mô tả theo tần suất mua: một lần và mua lặp lại.</a:t>
             </a:r>
           </a:p>
         </p:txBody>
@@ -32606,7 +32636,7 @@
                 <a:ea typeface="Arial"/>
                 <a:cs typeface="Arial"/>
               </a:rPr>
-              <a:t>DỰ ĐOÁN MUA LẠI</a:t>
+              <a:t>MÔ HÌNH MUA LẠI</a:t>
             </a:r>
           </a:p>
         </p:txBody>
@@ -32765,7 +32795,7 @@
                 <a:ea typeface="Arial"/>
                 <a:cs typeface="Arial"/>
               </a:rPr>
-              <a:t>DEV chưa xác nhận tín hiệu mua lại</a:t>
+              <a:t>Xếp hạng khả năng mua lại</a:t>
             </a:r>
           </a:p>
         </p:txBody>
@@ -33273,7 +33303,7 @@
                 <a:ea typeface="Arial"/>
                 <a:cs typeface="Arial"/>
               </a:rPr>
-              <a:t>0,500</a:t>
+              <a:t>RFM</a:t>
             </a:r>
           </a:p>
         </p:txBody>
@@ -33432,7 +33462,7 @@
                 <a:ea typeface="Arial"/>
                 <a:cs typeface="Arial"/>
               </a:rPr>
-              <a:t>Baseline</a:t>
+              <a:t>Đầu vào</a:t>
             </a:r>
           </a:p>
         </p:txBody>
@@ -33591,7 +33621,7 @@
                 <a:ea typeface="Arial"/>
                 <a:cs typeface="Arial"/>
               </a:rPr>
-              <a:t>0,5096</a:t>
+              <a:t>Logistic</a:t>
             </a:r>
           </a:p>
         </p:txBody>
@@ -33750,7 +33780,7 @@
                 <a:ea typeface="Arial"/>
                 <a:cs typeface="Arial"/>
               </a:rPr>
-              <a:t>LR C=10 · DEV OOF</a:t>
+              <a:t>Mô hình</a:t>
             </a:r>
           </a:p>
         </p:txBody>
@@ -33909,7 +33939,7 @@
                 <a:ea typeface="Arial"/>
                 <a:cs typeface="Arial"/>
               </a:rPr>
-              <a:t>0,7024</a:t>
+              <a:t>180 ngày</a:t>
             </a:r>
           </a:p>
         </p:txBody>
@@ -34068,7 +34098,7 @@
                 <a:ea typeface="Arial"/>
                 <a:cs typeface="Arial"/>
               </a:rPr>
-              <a:t>LR C=10 · test</a:t>
+              <a:t>Khoảng dự báo</a:t>
             </a:r>
           </a:p>
         </p:txBody>
@@ -34227,7 +34257,7 @@
                 <a:ea typeface="Arial"/>
                 <a:cs typeface="Arial"/>
               </a:rPr>
-              <a:t>14.394</a:t>
+              <a:t>5</a:t>
             </a:r>
           </a:p>
         </p:txBody>
@@ -34386,7 +34416,7 @@
                 <a:ea typeface="Arial"/>
                 <a:cs typeface="Arial"/>
               </a:rPr>
-              <a:t>snapshot OOF DEV</a:t>
+              <a:t>fold thời gian</a:t>
             </a:r>
           </a:p>
         </p:txBody>
@@ -34545,7 +34575,7 @@
                 <a:ea typeface="Arial"/>
                 <a:cs typeface="Arial"/>
               </a:rPr>
-              <a:t>4,17%</a:t>
+              <a:t>trước T</a:t>
             </a:r>
           </a:p>
         </p:txBody>
@@ -34704,7 +34734,7 @@
                 <a:ea typeface="Arial"/>
                 <a:cs typeface="Arial"/>
               </a:rPr>
-              <a:t>tỷ lệ dương OOF</a:t>
+              <a:t>không rò rỉ tương lai</a:t>
             </a:r>
           </a:p>
         </p:txBody>
@@ -35084,7 +35114,7 @@
                 <a:ea typeface="Arial"/>
                 <a:cs typeface="Arial"/>
               </a:rPr>
-              <a:t>Đánh giá theo thời gian, khóa test một lần</a:t>
+              <a:t>Tạo đặc trưng và nhãn mua lại</a:t>
             </a:r>
           </a:p>
         </p:txBody>
@@ -35592,7 +35622,7 @@
                 <a:ea typeface="Arial"/>
                 <a:cs typeface="Arial"/>
               </a:rPr>
-              <a:t>1</a:t>
+              <a:t>01</a:t>
             </a:r>
           </a:p>
         </p:txBody>
@@ -35751,7 +35781,7 @@
                 <a:ea typeface="Arial"/>
                 <a:cs typeface="Arial"/>
               </a:rPr>
-              <a:t>Feature trước T</a:t>
+              <a:t>Đặc trưng trước T</a:t>
             </a:r>
           </a:p>
         </p:txBody>
@@ -35910,7 +35940,7 @@
                 <a:ea typeface="Arial"/>
                 <a:cs typeface="Arial"/>
               </a:rPr>
-              <a:t>Chỉ dùng dữ liệu đã biết tại mốc T</a:t>
+              <a:t>RFM, giá trị đơn và nhịp mua từ lịch sử trước T</a:t>
             </a:r>
           </a:p>
         </p:txBody>
@@ -36100,7 +36130,7 @@
                 <a:ea typeface="Arial"/>
                 <a:cs typeface="Arial"/>
               </a:rPr>
-              <a:t>2</a:t>
+              <a:t>02</a:t>
             </a:r>
           </a:p>
         </p:txBody>
@@ -36259,7 +36289,7 @@
                 <a:ea typeface="Arial"/>
                 <a:cs typeface="Arial"/>
               </a:rPr>
-              <a:t>DEV rolling-origin</a:t>
+              <a:t>Nhãn mua lại</a:t>
             </a:r>
           </a:p>
         </p:txBody>
@@ -36418,7 +36448,7 @@
                 <a:ea typeface="Arial"/>
                 <a:cs typeface="Arial"/>
               </a:rPr>
-              <a:t>Train/validation theo thời gian; baseline cạnh mô hình</a:t>
+              <a:t>Có đơn hợp lệ trong 180 ngày sau T</a:t>
             </a:r>
           </a:p>
         </p:txBody>
@@ -36608,7 +36638,7 @@
                 <a:ea typeface="Arial"/>
                 <a:cs typeface="Arial"/>
               </a:rPr>
-              <a:t>3</a:t>
+              <a:t>03</a:t>
             </a:r>
           </a:p>
         </p:txBody>
@@ -36767,7 +36797,7 @@
                 <a:ea typeface="Arial"/>
                 <a:cs typeface="Arial"/>
               </a:rPr>
-              <a:t>Test holdout</a:t>
+              <a:t>Đánh giá</a:t>
             </a:r>
           </a:p>
         </p:txBody>
@@ -36926,7 +36956,7 @@
                 <a:ea typeface="Arial"/>
                 <a:cs typeface="Arial"/>
               </a:rPr>
-              <a:t>5.169 khách; mở một lần; bootstrap theo khách</a:t>
+              <a:t>So sánh theo các mốc thời gian, tránh trộn quá khứ và tương lai</a:t>
             </a:r>
           </a:p>
         </p:txBody>
@@ -37118,7 +37148,7 @@
                 <a:ea typeface="Arial"/>
                 <a:cs typeface="Arial"/>
               </a:rPr>
-              <a:t>Caveat protocol</a:t>
+              <a:t>Nguyên tắc</a:t>
             </a:r>
           </a:p>
         </p:txBody>
@@ -37277,7 +37307,7 @@
                 <a:ea typeface="Arial"/>
                 <a:cs typeface="Arial"/>
               </a:rPr>
-              <a:t>Cấu hình ghi &gt;T; evaluator dùng [T,end), gồm ngày T. Ảnh hưởng chưa xác định.</a:t>
+              <a:t>Mọi feature chỉ dùng thông tin đã có trước thời điểm dự đoán.</a:t>
             </a:r>
           </a:p>
         </p:txBody>

</xml_diff>